<commit_message>
fix: remove seed round ask from investor deck
Removed THE ASK slide (€120K breakdown) and all "Seed Round"
references. Deck now focuses purely on product/technology.
</commit_message>
<xml_diff>
--- a/public/Deep-Check_Investor_Deck.pptx
+++ b/public/Deep-Check_Investor_Deck.pptx
@@ -15,7 +15,6 @@
     <p:sldId id="263" r:id="rId9"/>
     <p:sldId id="264" r:id="rId10"/>
     <p:sldId id="265" r:id="rId11"/>
-    <p:sldId id="266" r:id="rId12"/>
     <p:sldId id="267" r:id="rId13"/>
   </p:sldIdLst>
   <p:notesMasterIdLst>
@@ -625,94 +624,6 @@
             <a:fld id="{F7021451-1387-4CA6-816F-3879F97B5CBC}" type="slidenum">
               <a:rPr lang="en-US"/>
               <a:t>10</a:t>
-            </a:fld>
-            <a:endParaRPr lang="en-US"/>
-          </a:p>
-        </p:txBody>
-      </p:sp>
-    </p:spTree>
-    <p:extLst>
-      <p:ext uri="{BB962C8B-B14F-4D97-AF65-F5344CB8AC3E}">
-        <p14:creationId xmlns:p14="http://schemas.microsoft.com/office/powerpoint/2010/main" val="1024086991"/>
-      </p:ext>
-    </p:extLst>
-  </p:cSld>
-  <p:clrMapOvr>
-    <a:masterClrMapping/>
-  </p:clrMapOvr>
-</p:notes>
-</file>
-
-<file path=ppt/notesSlides/notesSlide11.xml><?xml version="1.0" encoding="utf-8"?>
-<p:notes xmlns:a="http://schemas.openxmlformats.org/drawingml/2006/main" xmlns:r="http://schemas.openxmlformats.org/officeDocument/2006/relationships" xmlns:p="http://schemas.openxmlformats.org/presentationml/2006/main">
-  <p:cSld>
-    <p:spTree>
-      <p:nvGrpSpPr>
-        <p:cNvPr id="1" name=""/>
-        <p:cNvGrpSpPr/>
-        <p:nvPr/>
-      </p:nvGrpSpPr>
-      <p:grpSpPr>
-        <a:xfrm>
-          <a:off x="0" y="0"/>
-          <a:ext cx="0" cy="0"/>
-          <a:chOff x="0" y="0"/>
-          <a:chExt cx="0" cy="0"/>
-        </a:xfrm>
-      </p:grpSpPr>
-      <p:sp>
-        <p:nvSpPr>
-          <p:cNvPr id="2" name="Slide Image Placeholder 1"/>
-          <p:cNvSpPr>
-            <a:spLocks noGrp="1" noRot="1" noChangeAspect="1"/>
-          </p:cNvSpPr>
-          <p:nvPr>
-            <p:ph type="sldImg"/>
-          </p:nvPr>
-        </p:nvSpPr>
-        <p:spPr/>
-      </p:sp>
-      <p:sp>
-        <p:nvSpPr>
-          <p:cNvPr id="3" name="Notes Placeholder 2"/>
-          <p:cNvSpPr>
-            <a:spLocks noGrp="1"/>
-          </p:cNvSpPr>
-          <p:nvPr>
-            <p:ph type="body" idx="1"/>
-          </p:nvPr>
-        </p:nvSpPr>
-        <p:spPr/>
-        <p:txBody>
-          <a:bodyPr/>
-          <a:lstStyle/>
-          <a:p>
-            <a:r>
-              <a:rPr lang="en-US" dirty="0"/>
-              <a:t/>
-            </a:r>
-            <a:endParaRPr lang="en-US" dirty="0"/>
-          </a:p>
-        </p:txBody>
-      </p:sp>
-      <p:sp>
-        <p:nvSpPr>
-          <p:cNvPr id="4" name="Slide Number Placeholder 3"/>
-          <p:cNvSpPr>
-            <a:spLocks noGrp="1"/>
-          </p:cNvSpPr>
-          <p:nvPr>
-            <p:ph type="sldNum" sz="quarter" idx="10"/>
-          </p:nvPr>
-        </p:nvSpPr>
-        <p:spPr/>
-        <p:txBody>
-          <a:bodyPr/>
-          <a:lstStyle/>
-          <a:p>
-            <a:fld id="{F7021451-1387-4CA6-816F-3879F97B5CBC}" type="slidenum">
-              <a:rPr lang="en-US"/>
-              <a:t>11</a:t>
             </a:fld>
             <a:endParaRPr lang="en-US"/>
           </a:p>
@@ -1873,6 +1784,10 @@
           </a:solidFill>
           <a:ln/>
         </p:spPr>
+        <p:txBody>
+          <a:bodyPr/>
+          <a:p/>
+        </p:txBody>
       </p:sp>
       <p:sp>
         <p:nvSpPr>
@@ -1893,6 +1808,10 @@
           </a:solidFill>
           <a:ln/>
         </p:spPr>
+        <p:txBody>
+          <a:bodyPr/>
+          <a:p/>
+        </p:txBody>
       </p:sp>
       <p:sp>
         <p:nvSpPr>
@@ -2036,7 +1955,7 @@
                 <a:ea typeface="Arial" pitchFamily="34" charset="-122"/>
                 <a:cs typeface="Arial" pitchFamily="34" charset="-120"/>
               </a:rPr>
-              <a:t>Seed Round  —  March 2026</a:t>
+              <a:t>March 2026</a:t>
             </a:r>
             <a:endParaRPr lang="en-US" sz="1400" dirty="0"/>
           </a:p>
@@ -2061,6 +1980,10 @@
           </a:solidFill>
           <a:ln/>
         </p:spPr>
+        <p:txBody>
+          <a:bodyPr/>
+          <a:p/>
+        </p:txBody>
       </p:sp>
       <p:sp>
         <p:nvSpPr>
@@ -2152,6 +2075,10 @@
           </a:solidFill>
           <a:ln/>
         </p:spPr>
+        <p:txBody>
+          <a:bodyPr/>
+          <a:p/>
+        </p:txBody>
       </p:sp>
       <p:sp>
         <p:nvSpPr>
@@ -2257,6 +2184,10 @@
             </a:outerShdw>
           </a:effectLst>
         </p:spPr>
+        <p:txBody>
+          <a:bodyPr/>
+          <a:p/>
+        </p:txBody>
       </p:sp>
       <p:sp>
         <p:nvSpPr>
@@ -2469,919 +2400,6 @@
               <a:t>frontend, backend, deployment, and sales.</a:t>
             </a:r>
             <a:endParaRPr lang="en-US" sz="1100" dirty="0"/>
-          </a:p>
-        </p:txBody>
-      </p:sp>
-    </p:spTree>
-  </p:cSld>
-  <p:clrMapOvr>
-    <a:masterClrMapping/>
-  </p:clrMapOvr>
-</p:sld>
-</file>
-
-<file path=ppt/slides/slide11.xml><?xml version="1.0" encoding="utf-8"?>
-<p:sld xmlns:a="http://schemas.openxmlformats.org/drawingml/2006/main" xmlns:r="http://schemas.openxmlformats.org/officeDocument/2006/relationships" xmlns:p="http://schemas.openxmlformats.org/presentationml/2006/main">
-  <p:cSld name="Slide 11">
-    <p:bg>
-      <p:bgPr>
-        <a:solidFill>
-          <a:srgbClr val="0D0D0D"/>
-        </a:solidFill>
-      </p:bgPr>
-    </p:bg>
-    <p:spTree>
-      <p:nvGrpSpPr>
-        <p:cNvPr id="1" name=""/>
-        <p:cNvGrpSpPr/>
-        <p:nvPr/>
-      </p:nvGrpSpPr>
-      <p:grpSpPr>
-        <a:xfrm>
-          <a:off x="0" y="0"/>
-          <a:ext cx="0" cy="0"/>
-          <a:chOff x="0" y="0"/>
-          <a:chExt cx="0" cy="0"/>
-        </a:xfrm>
-      </p:grpSpPr>
-      <p:sp>
-        <p:nvSpPr>
-          <p:cNvPr id="2" name="Shape 0"/>
-          <p:cNvSpPr/>
-          <p:nvPr/>
-        </p:nvSpPr>
-        <p:spPr>
-          <a:xfrm>
-            <a:off x="0" y="0"/>
-            <a:ext cx="9144000" cy="54864"/>
-          </a:xfrm>
-          <a:prstGeom prst="rect">
-            <a:avLst/>
-          </a:prstGeom>
-          <a:solidFill>
-            <a:srgbClr val="00FF88"/>
-          </a:solidFill>
-          <a:ln/>
-        </p:spPr>
-      </p:sp>
-      <p:sp>
-        <p:nvSpPr>
-          <p:cNvPr id="3" name="Text 1"/>
-          <p:cNvSpPr/>
-          <p:nvPr/>
-        </p:nvSpPr>
-        <p:spPr>
-          <a:xfrm>
-            <a:off x="548640" y="320040"/>
-            <a:ext cx="2743200" cy="274320"/>
-          </a:xfrm>
-          <a:prstGeom prst="rect">
-            <a:avLst/>
-          </a:prstGeom>
-          <a:noFill/>
-          <a:ln/>
-        </p:spPr>
-        <p:txBody>
-          <a:bodyPr wrap="square" lIns="0" tIns="0" rIns="0" bIns="0" rtlCol="0" anchor="ctr"/>
-          <a:lstStyle/>
-          <a:p>
-            <a:pPr indent="0" marL="0">
-              <a:buNone/>
-            </a:pPr>
-            <a:r>
-              <a:rPr lang="en-US" sz="1000" b="1" spc="400" kern="0" dirty="0">
-                <a:solidFill>
-                  <a:srgbClr val="00FF88"/>
-                </a:solidFill>
-                <a:latin typeface="Arial" pitchFamily="34" charset="0"/>
-                <a:ea typeface="Arial" pitchFamily="34" charset="-122"/>
-                <a:cs typeface="Arial" pitchFamily="34" charset="-120"/>
-              </a:rPr>
-              <a:t>THE ASK</a:t>
-            </a:r>
-            <a:endParaRPr lang="en-US" sz="1000" dirty="0"/>
-          </a:p>
-        </p:txBody>
-      </p:sp>
-      <p:sp>
-        <p:nvSpPr>
-          <p:cNvPr id="4" name="Text 2"/>
-          <p:cNvSpPr/>
-          <p:nvPr/>
-        </p:nvSpPr>
-        <p:spPr>
-          <a:xfrm>
-            <a:off x="548640" y="594360"/>
-            <a:ext cx="7772400" cy="502920"/>
-          </a:xfrm>
-          <a:prstGeom prst="rect">
-            <a:avLst/>
-          </a:prstGeom>
-          <a:noFill/>
-          <a:ln/>
-        </p:spPr>
-        <p:txBody>
-          <a:bodyPr wrap="square" lIns="0" tIns="0" rIns="0" bIns="0" rtlCol="0" anchor="ctr"/>
-          <a:lstStyle/>
-          <a:p>
-            <a:pPr indent="0" marL="0">
-              <a:buNone/>
-            </a:pPr>
-            <a:r>
-              <a:rPr lang="en-US" sz="3200" b="1" dirty="0">
-                <a:solidFill>
-                  <a:srgbClr val="FFFFFF"/>
-                </a:solidFill>
-                <a:latin typeface="Arial" pitchFamily="34" charset="0"/>
-                <a:ea typeface="Arial" pitchFamily="34" charset="-122"/>
-                <a:cs typeface="Arial" pitchFamily="34" charset="-120"/>
-              </a:rPr>
-              <a:t>Seed round to accelerate.</a:t>
-            </a:r>
-            <a:endParaRPr lang="en-US" sz="3200" dirty="0"/>
-          </a:p>
-        </p:txBody>
-      </p:sp>
-      <p:sp>
-        <p:nvSpPr>
-          <p:cNvPr id="5" name="Text 3"/>
-          <p:cNvSpPr/>
-          <p:nvPr/>
-        </p:nvSpPr>
-        <p:spPr>
-          <a:xfrm>
-            <a:off x="548640" y="1371600"/>
-            <a:ext cx="3657600" cy="320040"/>
-          </a:xfrm>
-          <a:prstGeom prst="rect">
-            <a:avLst/>
-          </a:prstGeom>
-          <a:noFill/>
-          <a:ln/>
-        </p:spPr>
-        <p:txBody>
-          <a:bodyPr wrap="square" lIns="0" tIns="0" rIns="0" bIns="0" rtlCol="0" anchor="ctr"/>
-          <a:lstStyle/>
-          <a:p>
-            <a:pPr indent="0" marL="0">
-              <a:buNone/>
-            </a:pPr>
-            <a:r>
-              <a:rPr lang="en-US" sz="1600" b="1" dirty="0">
-                <a:solidFill>
-                  <a:srgbClr val="FFFFFF"/>
-                </a:solidFill>
-                <a:latin typeface="Arial" pitchFamily="34" charset="0"/>
-                <a:ea typeface="Arial" pitchFamily="34" charset="-122"/>
-                <a:cs typeface="Arial" pitchFamily="34" charset="-120"/>
-              </a:rPr>
-              <a:t>Use of Funds</a:t>
-            </a:r>
-            <a:endParaRPr lang="en-US" sz="1600" dirty="0"/>
-          </a:p>
-        </p:txBody>
-      </p:sp>
-      <p:sp>
-        <p:nvSpPr>
-          <p:cNvPr id="6" name="Shape 4"/>
-          <p:cNvSpPr/>
-          <p:nvPr/>
-        </p:nvSpPr>
-        <p:spPr>
-          <a:xfrm>
-            <a:off x="548640" y="1828800"/>
-            <a:ext cx="8046720" cy="502920"/>
-          </a:xfrm>
-          <a:prstGeom prst="rect">
-            <a:avLst/>
-          </a:prstGeom>
-          <a:solidFill>
-            <a:srgbClr val="1E1E1E"/>
-          </a:solidFill>
-          <a:ln/>
-        </p:spPr>
-      </p:sp>
-      <p:sp>
-        <p:nvSpPr>
-          <p:cNvPr id="7" name="Text 5"/>
-          <p:cNvSpPr/>
-          <p:nvPr/>
-        </p:nvSpPr>
-        <p:spPr>
-          <a:xfrm>
-            <a:off x="731520" y="1874520"/>
-            <a:ext cx="4114800" cy="201168"/>
-          </a:xfrm>
-          <a:prstGeom prst="rect">
-            <a:avLst/>
-          </a:prstGeom>
-          <a:noFill/>
-          <a:ln/>
-        </p:spPr>
-        <p:txBody>
-          <a:bodyPr wrap="square" lIns="0" tIns="0" rIns="0" bIns="0" rtlCol="0" anchor="ctr"/>
-          <a:lstStyle/>
-          <a:p>
-            <a:pPr indent="0" marL="0">
-              <a:buNone/>
-            </a:pPr>
-            <a:r>
-              <a:rPr lang="en-US" sz="1300" b="1" dirty="0">
-                <a:solidFill>
-                  <a:srgbClr val="FFFFFF"/>
-                </a:solidFill>
-                <a:latin typeface="Arial" pitchFamily="34" charset="0"/>
-                <a:ea typeface="Arial" pitchFamily="34" charset="-122"/>
-                <a:cs typeface="Arial" pitchFamily="34" charset="-120"/>
-              </a:rPr>
-              <a:t>iBeta ISO 30107-3 Certification</a:t>
-            </a:r>
-            <a:endParaRPr lang="en-US" sz="1300" dirty="0"/>
-          </a:p>
-        </p:txBody>
-      </p:sp>
-      <p:sp>
-        <p:nvSpPr>
-          <p:cNvPr id="8" name="Text 6"/>
-          <p:cNvSpPr/>
-          <p:nvPr/>
-        </p:nvSpPr>
-        <p:spPr>
-          <a:xfrm>
-            <a:off x="731520" y="2084832"/>
-            <a:ext cx="4114800" cy="182880"/>
-          </a:xfrm>
-          <a:prstGeom prst="rect">
-            <a:avLst/>
-          </a:prstGeom>
-          <a:noFill/>
-          <a:ln/>
-        </p:spPr>
-        <p:txBody>
-          <a:bodyPr wrap="square" lIns="0" tIns="0" rIns="0" bIns="0" rtlCol="0" anchor="ctr"/>
-          <a:lstStyle/>
-          <a:p>
-            <a:pPr indent="0" marL="0">
-              <a:buNone/>
-            </a:pPr>
-            <a:r>
-              <a:rPr lang="en-US" sz="1000" dirty="0">
-                <a:solidFill>
-                  <a:srgbClr val="888888"/>
-                </a:solidFill>
-                <a:latin typeface="Arial" pitchFamily="34" charset="0"/>
-                <a:ea typeface="Arial" pitchFamily="34" charset="-122"/>
-                <a:cs typeface="Arial" pitchFamily="34" charset="-120"/>
-              </a:rPr>
-              <a:t>Official liveness detection certification</a:t>
-            </a:r>
-            <a:endParaRPr lang="en-US" sz="1000" dirty="0"/>
-          </a:p>
-        </p:txBody>
-      </p:sp>
-      <p:sp>
-        <p:nvSpPr>
-          <p:cNvPr id="9" name="Text 7"/>
-          <p:cNvSpPr/>
-          <p:nvPr/>
-        </p:nvSpPr>
-        <p:spPr>
-          <a:xfrm>
-            <a:off x="6858000" y="1874520"/>
-            <a:ext cx="1554480" cy="411480"/>
-          </a:xfrm>
-          <a:prstGeom prst="rect">
-            <a:avLst/>
-          </a:prstGeom>
-          <a:noFill/>
-          <a:ln/>
-        </p:spPr>
-        <p:txBody>
-          <a:bodyPr wrap="square" lIns="0" tIns="0" rIns="0" bIns="0" rtlCol="0" anchor="ctr"/>
-          <a:lstStyle/>
-          <a:p>
-            <a:pPr algn="r" indent="0" marL="0">
-              <a:buNone/>
-            </a:pPr>
-            <a:r>
-              <a:rPr lang="en-US" sz="2000" b="1" dirty="0">
-                <a:solidFill>
-                  <a:srgbClr val="00FF88"/>
-                </a:solidFill>
-                <a:latin typeface="Arial" pitchFamily="34" charset="0"/>
-                <a:ea typeface="Arial" pitchFamily="34" charset="-122"/>
-                <a:cs typeface="Arial" pitchFamily="34" charset="-120"/>
-              </a:rPr>
-              <a:t>€30K</a:t>
-            </a:r>
-            <a:endParaRPr lang="en-US" sz="2000" dirty="0"/>
-          </a:p>
-        </p:txBody>
-      </p:sp>
-      <p:sp>
-        <p:nvSpPr>
-          <p:cNvPr id="10" name="Shape 8"/>
-          <p:cNvSpPr/>
-          <p:nvPr/>
-        </p:nvSpPr>
-        <p:spPr>
-          <a:xfrm>
-            <a:off x="548640" y="2423160"/>
-            <a:ext cx="8046720" cy="502920"/>
-          </a:xfrm>
-          <a:prstGeom prst="rect">
-            <a:avLst/>
-          </a:prstGeom>
-          <a:solidFill>
-            <a:srgbClr val="0D0D0D"/>
-          </a:solidFill>
-          <a:ln/>
-        </p:spPr>
-      </p:sp>
-      <p:sp>
-        <p:nvSpPr>
-          <p:cNvPr id="11" name="Text 9"/>
-          <p:cNvSpPr/>
-          <p:nvPr/>
-        </p:nvSpPr>
-        <p:spPr>
-          <a:xfrm>
-            <a:off x="731520" y="2468880"/>
-            <a:ext cx="4114800" cy="201168"/>
-          </a:xfrm>
-          <a:prstGeom prst="rect">
-            <a:avLst/>
-          </a:prstGeom>
-          <a:noFill/>
-          <a:ln/>
-        </p:spPr>
-        <p:txBody>
-          <a:bodyPr wrap="square" lIns="0" tIns="0" rIns="0" bIns="0" rtlCol="0" anchor="ctr"/>
-          <a:lstStyle/>
-          <a:p>
-            <a:pPr indent="0" marL="0">
-              <a:buNone/>
-            </a:pPr>
-            <a:r>
-              <a:rPr lang="en-US" sz="1300" b="1" dirty="0">
-                <a:solidFill>
-                  <a:srgbClr val="FFFFFF"/>
-                </a:solidFill>
-                <a:latin typeface="Arial" pitchFamily="34" charset="0"/>
-                <a:ea typeface="Arial" pitchFamily="34" charset="-122"/>
-                <a:cs typeface="Arial" pitchFamily="34" charset="-120"/>
-              </a:rPr>
-              <a:t>NIST FATE PAD Submission</a:t>
-            </a:r>
-            <a:endParaRPr lang="en-US" sz="1300" dirty="0"/>
-          </a:p>
-        </p:txBody>
-      </p:sp>
-      <p:sp>
-        <p:nvSpPr>
-          <p:cNvPr id="12" name="Text 10"/>
-          <p:cNvSpPr/>
-          <p:nvPr/>
-        </p:nvSpPr>
-        <p:spPr>
-          <a:xfrm>
-            <a:off x="731520" y="2679192"/>
-            <a:ext cx="4114800" cy="182880"/>
-          </a:xfrm>
-          <a:prstGeom prst="rect">
-            <a:avLst/>
-          </a:prstGeom>
-          <a:noFill/>
-          <a:ln/>
-        </p:spPr>
-        <p:txBody>
-          <a:bodyPr wrap="square" lIns="0" tIns="0" rIns="0" bIns="0" rtlCol="0" anchor="ctr"/>
-          <a:lstStyle/>
-          <a:p>
-            <a:pPr indent="0" marL="0">
-              <a:buNone/>
-            </a:pPr>
-            <a:r>
-              <a:rPr lang="en-US" sz="1000" dirty="0">
-                <a:solidFill>
-                  <a:srgbClr val="888888"/>
-                </a:solidFill>
-                <a:latin typeface="Arial" pitchFamily="34" charset="0"/>
-                <a:ea typeface="Arial" pitchFamily="34" charset="-122"/>
-                <a:cs typeface="Arial" pitchFamily="34" charset="-120"/>
-              </a:rPr>
-              <a:t>Government-grade validation</a:t>
-            </a:r>
-            <a:endParaRPr lang="en-US" sz="1000" dirty="0"/>
-          </a:p>
-        </p:txBody>
-      </p:sp>
-      <p:sp>
-        <p:nvSpPr>
-          <p:cNvPr id="13" name="Text 11"/>
-          <p:cNvSpPr/>
-          <p:nvPr/>
-        </p:nvSpPr>
-        <p:spPr>
-          <a:xfrm>
-            <a:off x="6858000" y="2468880"/>
-            <a:ext cx="1554480" cy="411480"/>
-          </a:xfrm>
-          <a:prstGeom prst="rect">
-            <a:avLst/>
-          </a:prstGeom>
-          <a:noFill/>
-          <a:ln/>
-        </p:spPr>
-        <p:txBody>
-          <a:bodyPr wrap="square" lIns="0" tIns="0" rIns="0" bIns="0" rtlCol="0" anchor="ctr"/>
-          <a:lstStyle/>
-          <a:p>
-            <a:pPr algn="r" indent="0" marL="0">
-              <a:buNone/>
-            </a:pPr>
-            <a:r>
-              <a:rPr lang="en-US" sz="2000" b="1" dirty="0">
-                <a:solidFill>
-                  <a:srgbClr val="00FF88"/>
-                </a:solidFill>
-                <a:latin typeface="Arial" pitchFamily="34" charset="0"/>
-                <a:ea typeface="Arial" pitchFamily="34" charset="-122"/>
-                <a:cs typeface="Arial" pitchFamily="34" charset="-120"/>
-              </a:rPr>
-              <a:t>€5K</a:t>
-            </a:r>
-            <a:endParaRPr lang="en-US" sz="2000" dirty="0"/>
-          </a:p>
-        </p:txBody>
-      </p:sp>
-      <p:sp>
-        <p:nvSpPr>
-          <p:cNvPr id="14" name="Shape 12"/>
-          <p:cNvSpPr/>
-          <p:nvPr/>
-        </p:nvSpPr>
-        <p:spPr>
-          <a:xfrm>
-            <a:off x="548640" y="3017520"/>
-            <a:ext cx="8046720" cy="502920"/>
-          </a:xfrm>
-          <a:prstGeom prst="rect">
-            <a:avLst/>
-          </a:prstGeom>
-          <a:solidFill>
-            <a:srgbClr val="1E1E1E"/>
-          </a:solidFill>
-          <a:ln/>
-        </p:spPr>
-      </p:sp>
-      <p:sp>
-        <p:nvSpPr>
-          <p:cNvPr id="15" name="Text 13"/>
-          <p:cNvSpPr/>
-          <p:nvPr/>
-        </p:nvSpPr>
-        <p:spPr>
-          <a:xfrm>
-            <a:off x="731520" y="3063240"/>
-            <a:ext cx="4114800" cy="201168"/>
-          </a:xfrm>
-          <a:prstGeom prst="rect">
-            <a:avLst/>
-          </a:prstGeom>
-          <a:noFill/>
-          <a:ln/>
-        </p:spPr>
-        <p:txBody>
-          <a:bodyPr wrap="square" lIns="0" tIns="0" rIns="0" bIns="0" rtlCol="0" anchor="ctr"/>
-          <a:lstStyle/>
-          <a:p>
-            <a:pPr indent="0" marL="0">
-              <a:buNone/>
-            </a:pPr>
-            <a:r>
-              <a:rPr lang="en-US" sz="1300" b="1" dirty="0">
-                <a:solidFill>
-                  <a:srgbClr val="FFFFFF"/>
-                </a:solidFill>
-                <a:latin typeface="Arial" pitchFamily="34" charset="0"/>
-                <a:ea typeface="Arial" pitchFamily="34" charset="-122"/>
-                <a:cs typeface="Arial" pitchFamily="34" charset="-120"/>
-              </a:rPr>
-              <a:t>First Enterprise PoC</a:t>
-            </a:r>
-            <a:endParaRPr lang="en-US" sz="1300" dirty="0"/>
-          </a:p>
-        </p:txBody>
-      </p:sp>
-      <p:sp>
-        <p:nvSpPr>
-          <p:cNvPr id="16" name="Text 14"/>
-          <p:cNvSpPr/>
-          <p:nvPr/>
-        </p:nvSpPr>
-        <p:spPr>
-          <a:xfrm>
-            <a:off x="731520" y="3273552"/>
-            <a:ext cx="4114800" cy="182880"/>
-          </a:xfrm>
-          <a:prstGeom prst="rect">
-            <a:avLst/>
-          </a:prstGeom>
-          <a:noFill/>
-          <a:ln/>
-        </p:spPr>
-        <p:txBody>
-          <a:bodyPr wrap="square" lIns="0" tIns="0" rIns="0" bIns="0" rtlCol="0" anchor="ctr"/>
-          <a:lstStyle/>
-          <a:p>
-            <a:pPr indent="0" marL="0">
-              <a:buNone/>
-            </a:pPr>
-            <a:r>
-              <a:rPr lang="en-US" sz="1000" dirty="0">
-                <a:solidFill>
-                  <a:srgbClr val="888888"/>
-                </a:solidFill>
-                <a:latin typeface="Arial" pitchFamily="34" charset="0"/>
-                <a:ea typeface="Arial" pitchFamily="34" charset="-122"/>
-                <a:cs typeface="Arial" pitchFamily="34" charset="-120"/>
-              </a:rPr>
-              <a:t>Pilot with Fintech/Crypto partner</a:t>
-            </a:r>
-            <a:endParaRPr lang="en-US" sz="1000" dirty="0"/>
-          </a:p>
-        </p:txBody>
-      </p:sp>
-      <p:sp>
-        <p:nvSpPr>
-          <p:cNvPr id="17" name="Text 15"/>
-          <p:cNvSpPr/>
-          <p:nvPr/>
-        </p:nvSpPr>
-        <p:spPr>
-          <a:xfrm>
-            <a:off x="6858000" y="3063240"/>
-            <a:ext cx="1554480" cy="411480"/>
-          </a:xfrm>
-          <a:prstGeom prst="rect">
-            <a:avLst/>
-          </a:prstGeom>
-          <a:noFill/>
-          <a:ln/>
-        </p:spPr>
-        <p:txBody>
-          <a:bodyPr wrap="square" lIns="0" tIns="0" rIns="0" bIns="0" rtlCol="0" anchor="ctr"/>
-          <a:lstStyle/>
-          <a:p>
-            <a:pPr algn="r" indent="0" marL="0">
-              <a:buNone/>
-            </a:pPr>
-            <a:r>
-              <a:rPr lang="en-US" sz="2000" b="1" dirty="0">
-                <a:solidFill>
-                  <a:srgbClr val="00FF88"/>
-                </a:solidFill>
-                <a:latin typeface="Arial" pitchFamily="34" charset="0"/>
-                <a:ea typeface="Arial" pitchFamily="34" charset="-122"/>
-                <a:cs typeface="Arial" pitchFamily="34" charset="-120"/>
-              </a:rPr>
-              <a:t>€15K</a:t>
-            </a:r>
-            <a:endParaRPr lang="en-US" sz="2000" dirty="0"/>
-          </a:p>
-        </p:txBody>
-      </p:sp>
-      <p:sp>
-        <p:nvSpPr>
-          <p:cNvPr id="18" name="Shape 16"/>
-          <p:cNvSpPr/>
-          <p:nvPr/>
-        </p:nvSpPr>
-        <p:spPr>
-          <a:xfrm>
-            <a:off x="548640" y="3611880"/>
-            <a:ext cx="8046720" cy="502920"/>
-          </a:xfrm>
-          <a:prstGeom prst="rect">
-            <a:avLst/>
-          </a:prstGeom>
-          <a:solidFill>
-            <a:srgbClr val="0D0D0D"/>
-          </a:solidFill>
-          <a:ln/>
-        </p:spPr>
-      </p:sp>
-      <p:sp>
-        <p:nvSpPr>
-          <p:cNvPr id="19" name="Text 17"/>
-          <p:cNvSpPr/>
-          <p:nvPr/>
-        </p:nvSpPr>
-        <p:spPr>
-          <a:xfrm>
-            <a:off x="731520" y="3657600"/>
-            <a:ext cx="4114800" cy="201168"/>
-          </a:xfrm>
-          <a:prstGeom prst="rect">
-            <a:avLst/>
-          </a:prstGeom>
-          <a:noFill/>
-          <a:ln/>
-        </p:spPr>
-        <p:txBody>
-          <a:bodyPr wrap="square" lIns="0" tIns="0" rIns="0" bIns="0" rtlCol="0" anchor="ctr"/>
-          <a:lstStyle/>
-          <a:p>
-            <a:pPr indent="0" marL="0">
-              <a:buNone/>
-            </a:pPr>
-            <a:r>
-              <a:rPr lang="en-US" sz="1300" b="1" dirty="0">
-                <a:solidFill>
-                  <a:srgbClr val="FFFFFF"/>
-                </a:solidFill>
-                <a:latin typeface="Arial" pitchFamily="34" charset="0"/>
-                <a:ea typeface="Arial" pitchFamily="34" charset="-122"/>
-                <a:cs typeface="Arial" pitchFamily="34" charset="-120"/>
-              </a:rPr>
-              <a:t>ML Engineer (6 months)</a:t>
-            </a:r>
-            <a:endParaRPr lang="en-US" sz="1300" dirty="0"/>
-          </a:p>
-        </p:txBody>
-      </p:sp>
-      <p:sp>
-        <p:nvSpPr>
-          <p:cNvPr id="20" name="Text 18"/>
-          <p:cNvSpPr/>
-          <p:nvPr/>
-        </p:nvSpPr>
-        <p:spPr>
-          <a:xfrm>
-            <a:off x="731520" y="3867912"/>
-            <a:ext cx="4114800" cy="182880"/>
-          </a:xfrm>
-          <a:prstGeom prst="rect">
-            <a:avLst/>
-          </a:prstGeom>
-          <a:noFill/>
-          <a:ln/>
-        </p:spPr>
-        <p:txBody>
-          <a:bodyPr wrap="square" lIns="0" tIns="0" rIns="0" bIns="0" rtlCol="0" anchor="ctr"/>
-          <a:lstStyle/>
-          <a:p>
-            <a:pPr indent="0" marL="0">
-              <a:buNone/>
-            </a:pPr>
-            <a:r>
-              <a:rPr lang="en-US" sz="1000" dirty="0">
-                <a:solidFill>
-                  <a:srgbClr val="888888"/>
-                </a:solidFill>
-                <a:latin typeface="Arial" pitchFamily="34" charset="0"/>
-                <a:ea typeface="Arial" pitchFamily="34" charset="-122"/>
-                <a:cs typeface="Arial" pitchFamily="34" charset="-120"/>
-              </a:rPr>
-              <a:t>Scale model training, add new attack types</a:t>
-            </a:r>
-            <a:endParaRPr lang="en-US" sz="1000" dirty="0"/>
-          </a:p>
-        </p:txBody>
-      </p:sp>
-      <p:sp>
-        <p:nvSpPr>
-          <p:cNvPr id="21" name="Text 19"/>
-          <p:cNvSpPr/>
-          <p:nvPr/>
-        </p:nvSpPr>
-        <p:spPr>
-          <a:xfrm>
-            <a:off x="6858000" y="3657600"/>
-            <a:ext cx="1554480" cy="411480"/>
-          </a:xfrm>
-          <a:prstGeom prst="rect">
-            <a:avLst/>
-          </a:prstGeom>
-          <a:noFill/>
-          <a:ln/>
-        </p:spPr>
-        <p:txBody>
-          <a:bodyPr wrap="square" lIns="0" tIns="0" rIns="0" bIns="0" rtlCol="0" anchor="ctr"/>
-          <a:lstStyle/>
-          <a:p>
-            <a:pPr algn="r" indent="0" marL="0">
-              <a:buNone/>
-            </a:pPr>
-            <a:r>
-              <a:rPr lang="en-US" sz="2000" b="1" dirty="0">
-                <a:solidFill>
-                  <a:srgbClr val="00FF88"/>
-                </a:solidFill>
-                <a:latin typeface="Arial" pitchFamily="34" charset="0"/>
-                <a:ea typeface="Arial" pitchFamily="34" charset="-122"/>
-                <a:cs typeface="Arial" pitchFamily="34" charset="-120"/>
-              </a:rPr>
-              <a:t>€40K</a:t>
-            </a:r>
-            <a:endParaRPr lang="en-US" sz="2000" dirty="0"/>
-          </a:p>
-        </p:txBody>
-      </p:sp>
-      <p:sp>
-        <p:nvSpPr>
-          <p:cNvPr id="22" name="Shape 20"/>
-          <p:cNvSpPr/>
-          <p:nvPr/>
-        </p:nvSpPr>
-        <p:spPr>
-          <a:xfrm>
-            <a:off x="548640" y="4206240"/>
-            <a:ext cx="8046720" cy="502920"/>
-          </a:xfrm>
-          <a:prstGeom prst="rect">
-            <a:avLst/>
-          </a:prstGeom>
-          <a:solidFill>
-            <a:srgbClr val="1E1E1E"/>
-          </a:solidFill>
-          <a:ln/>
-        </p:spPr>
-      </p:sp>
-      <p:sp>
-        <p:nvSpPr>
-          <p:cNvPr id="23" name="Text 21"/>
-          <p:cNvSpPr/>
-          <p:nvPr/>
-        </p:nvSpPr>
-        <p:spPr>
-          <a:xfrm>
-            <a:off x="731520" y="4251960"/>
-            <a:ext cx="4114800" cy="201168"/>
-          </a:xfrm>
-          <a:prstGeom prst="rect">
-            <a:avLst/>
-          </a:prstGeom>
-          <a:noFill/>
-          <a:ln/>
-        </p:spPr>
-        <p:txBody>
-          <a:bodyPr wrap="square" lIns="0" tIns="0" rIns="0" bIns="0" rtlCol="0" anchor="ctr"/>
-          <a:lstStyle/>
-          <a:p>
-            <a:pPr indent="0" marL="0">
-              <a:buNone/>
-            </a:pPr>
-            <a:r>
-              <a:rPr lang="en-US" sz="1300" b="1" dirty="0">
-                <a:solidFill>
-                  <a:srgbClr val="FFFFFF"/>
-                </a:solidFill>
-                <a:latin typeface="Arial" pitchFamily="34" charset="0"/>
-                <a:ea typeface="Arial" pitchFamily="34" charset="-122"/>
-                <a:cs typeface="Arial" pitchFamily="34" charset="-120"/>
-              </a:rPr>
-              <a:t>Sales &amp; BD (6 months)</a:t>
-            </a:r>
-            <a:endParaRPr lang="en-US" sz="1300" dirty="0"/>
-          </a:p>
-        </p:txBody>
-      </p:sp>
-      <p:sp>
-        <p:nvSpPr>
-          <p:cNvPr id="24" name="Text 22"/>
-          <p:cNvSpPr/>
-          <p:nvPr/>
-        </p:nvSpPr>
-        <p:spPr>
-          <a:xfrm>
-            <a:off x="731520" y="4462272"/>
-            <a:ext cx="4114800" cy="182880"/>
-          </a:xfrm>
-          <a:prstGeom prst="rect">
-            <a:avLst/>
-          </a:prstGeom>
-          <a:noFill/>
-          <a:ln/>
-        </p:spPr>
-        <p:txBody>
-          <a:bodyPr wrap="square" lIns="0" tIns="0" rIns="0" bIns="0" rtlCol="0" anchor="ctr"/>
-          <a:lstStyle/>
-          <a:p>
-            <a:pPr indent="0" marL="0">
-              <a:buNone/>
-            </a:pPr>
-            <a:r>
-              <a:rPr lang="en-US" sz="1000" dirty="0">
-                <a:solidFill>
-                  <a:srgbClr val="888888"/>
-                </a:solidFill>
-                <a:latin typeface="Arial" pitchFamily="34" charset="0"/>
-                <a:ea typeface="Arial" pitchFamily="34" charset="-122"/>
-                <a:cs typeface="Arial" pitchFamily="34" charset="-120"/>
-              </a:rPr>
-              <a:t>Enterprise pipeline, partnerships</a:t>
-            </a:r>
-            <a:endParaRPr lang="en-US" sz="1000" dirty="0"/>
-          </a:p>
-        </p:txBody>
-      </p:sp>
-      <p:sp>
-        <p:nvSpPr>
-          <p:cNvPr id="25" name="Text 23"/>
-          <p:cNvSpPr/>
-          <p:nvPr/>
-        </p:nvSpPr>
-        <p:spPr>
-          <a:xfrm>
-            <a:off x="6858000" y="4251960"/>
-            <a:ext cx="1554480" cy="411480"/>
-          </a:xfrm>
-          <a:prstGeom prst="rect">
-            <a:avLst/>
-          </a:prstGeom>
-          <a:noFill/>
-          <a:ln/>
-        </p:spPr>
-        <p:txBody>
-          <a:bodyPr wrap="square" lIns="0" tIns="0" rIns="0" bIns="0" rtlCol="0" anchor="ctr"/>
-          <a:lstStyle/>
-          <a:p>
-            <a:pPr algn="r" indent="0" marL="0">
-              <a:buNone/>
-            </a:pPr>
-            <a:r>
-              <a:rPr lang="en-US" sz="2000" b="1" dirty="0">
-                <a:solidFill>
-                  <a:srgbClr val="00FF88"/>
-                </a:solidFill>
-                <a:latin typeface="Arial" pitchFamily="34" charset="0"/>
-                <a:ea typeface="Arial" pitchFamily="34" charset="-122"/>
-                <a:cs typeface="Arial" pitchFamily="34" charset="-120"/>
-              </a:rPr>
-              <a:t>€30K</a:t>
-            </a:r>
-            <a:endParaRPr lang="en-US" sz="2000" dirty="0"/>
-          </a:p>
-        </p:txBody>
-      </p:sp>
-      <p:sp>
-        <p:nvSpPr>
-          <p:cNvPr id="26" name="Shape 24"/>
-          <p:cNvSpPr/>
-          <p:nvPr/>
-        </p:nvSpPr>
-        <p:spPr>
-          <a:xfrm>
-            <a:off x="548640" y="4846320"/>
-            <a:ext cx="8046720" cy="54864"/>
-          </a:xfrm>
-          <a:prstGeom prst="rect">
-            <a:avLst/>
-          </a:prstGeom>
-          <a:solidFill>
-            <a:srgbClr val="00FF88"/>
-          </a:solidFill>
-          <a:ln/>
-        </p:spPr>
-      </p:sp>
-      <p:sp>
-        <p:nvSpPr>
-          <p:cNvPr id="27" name="Text 25"/>
-          <p:cNvSpPr/>
-          <p:nvPr/>
-        </p:nvSpPr>
-        <p:spPr>
-          <a:xfrm>
-            <a:off x="5029200" y="4572000"/>
-            <a:ext cx="3566160" cy="320040"/>
-          </a:xfrm>
-          <a:prstGeom prst="rect">
-            <a:avLst/>
-          </a:prstGeom>
-          <a:noFill/>
-          <a:ln/>
-        </p:spPr>
-        <p:txBody>
-          <a:bodyPr wrap="square" lIns="0" tIns="0" rIns="0" bIns="0" rtlCol="0" anchor="ctr"/>
-          <a:lstStyle/>
-          <a:p>
-            <a:pPr algn="r" indent="0" marL="0">
-              <a:buNone/>
-            </a:pPr>
-            <a:r>
-              <a:rPr lang="en-US" sz="1800" b="1" dirty="0">
-                <a:solidFill>
-                  <a:srgbClr val="00FF88"/>
-                </a:solidFill>
-                <a:latin typeface="Arial" pitchFamily="34" charset="0"/>
-                <a:ea typeface="Arial" pitchFamily="34" charset="-122"/>
-                <a:cs typeface="Arial" pitchFamily="34" charset="-120"/>
-              </a:rPr>
-              <a:t>Total: ~€120K</a:t>
-            </a:r>
-            <a:endParaRPr lang="en-US" sz="1800" dirty="0"/>
           </a:p>
         </p:txBody>
       </p:sp>
@@ -3436,6 +2454,10 @@
           </a:solidFill>
           <a:ln/>
         </p:spPr>
+        <p:txBody>
+          <a:bodyPr/>
+          <a:p/>
+        </p:txBody>
       </p:sp>
       <p:sp>
         <p:nvSpPr>
@@ -3549,6 +2571,10 @@
             </a:outerShdw>
           </a:effectLst>
         </p:spPr>
+        <p:txBody>
+          <a:bodyPr/>
+          <a:p/>
+        </p:txBody>
       </p:sp>
       <p:sp>
         <p:nvSpPr>
@@ -3654,6 +2680,10 @@
             </a:outerShdw>
           </a:effectLst>
         </p:spPr>
+        <p:txBody>
+          <a:bodyPr/>
+          <a:p/>
+        </p:txBody>
       </p:sp>
       <p:sp>
         <p:nvSpPr>
@@ -3759,6 +2789,10 @@
             </a:outerShdw>
           </a:effectLst>
         </p:spPr>
+        <p:txBody>
+          <a:bodyPr/>
+          <a:p/>
+        </p:txBody>
       </p:sp>
       <p:sp>
         <p:nvSpPr>
@@ -3871,7 +2905,7 @@
                 <a:ea typeface="Arial" pitchFamily="34" charset="-122"/>
                 <a:cs typeface="Arial" pitchFamily="34" charset="-120"/>
               </a:rPr>
-              <a:t>HIUM Solutions SL  |  Andalucia, Spain  |  Seed Round 2026</a:t>
+              <a:t>HIUM Solutions SL  |  Andalucia, Spain  |  2026</a:t>
             </a:r>
             <a:endParaRPr lang="en-US" sz="1000" dirty="0"/>
           </a:p>
@@ -3928,6 +2962,10 @@
           </a:solidFill>
           <a:ln/>
         </p:spPr>
+        <p:txBody>
+          <a:bodyPr/>
+          <a:p/>
+        </p:txBody>
       </p:sp>
       <p:sp>
         <p:nvSpPr>
@@ -4128,6 +3166,10 @@
             </a:outerShdw>
           </a:effectLst>
         </p:spPr>
+        <p:txBody>
+          <a:bodyPr/>
+          <a:p/>
+        </p:txBody>
       </p:sp>
       <p:sp>
         <p:nvSpPr>
@@ -4148,6 +3190,10 @@
           </a:solidFill>
           <a:ln/>
         </p:spPr>
+        <p:txBody>
+          <a:bodyPr/>
+          <a:p/>
+        </p:txBody>
       </p:sp>
       <p:sp>
         <p:nvSpPr>
@@ -4253,6 +3299,10 @@
             </a:outerShdw>
           </a:effectLst>
         </p:spPr>
+        <p:txBody>
+          <a:bodyPr/>
+          <a:p/>
+        </p:txBody>
       </p:sp>
       <p:sp>
         <p:nvSpPr>
@@ -4273,6 +3323,10 @@
           </a:solidFill>
           <a:ln/>
         </p:spPr>
+        <p:txBody>
+          <a:bodyPr/>
+          <a:p/>
+        </p:txBody>
       </p:sp>
       <p:sp>
         <p:nvSpPr>
@@ -4378,6 +3432,10 @@
             </a:outerShdw>
           </a:effectLst>
         </p:spPr>
+        <p:txBody>
+          <a:bodyPr/>
+          <a:p/>
+        </p:txBody>
       </p:sp>
       <p:sp>
         <p:nvSpPr>
@@ -4398,6 +3456,10 @@
           </a:solidFill>
           <a:ln/>
         </p:spPr>
+        <p:txBody>
+          <a:bodyPr/>
+          <a:p/>
+        </p:txBody>
       </p:sp>
       <p:sp>
         <p:nvSpPr>
@@ -4528,6 +3590,10 @@
           </a:solidFill>
           <a:ln/>
         </p:spPr>
+        <p:txBody>
+          <a:bodyPr/>
+          <a:p/>
+        </p:txBody>
       </p:sp>
       <p:sp>
         <p:nvSpPr>
@@ -4626,6 +3692,10 @@
           </a:solidFill>
           <a:ln/>
         </p:spPr>
+        <p:txBody>
+          <a:bodyPr/>
+          <a:p/>
+        </p:txBody>
       </p:sp>
       <p:sp>
         <p:nvSpPr>
@@ -4692,6 +3762,10 @@
             </a:outerShdw>
           </a:effectLst>
         </p:spPr>
+        <p:txBody>
+          <a:bodyPr/>
+          <a:p/>
+        </p:txBody>
       </p:sp>
       <p:sp>
         <p:nvSpPr>
@@ -4712,6 +3786,10 @@
           </a:solidFill>
           <a:ln/>
         </p:spPr>
+        <p:txBody>
+          <a:bodyPr/>
+          <a:p/>
+        </p:txBody>
       </p:sp>
       <p:sp>
         <p:nvSpPr>
@@ -4817,6 +3895,10 @@
             </a:outerShdw>
           </a:effectLst>
         </p:spPr>
+        <p:txBody>
+          <a:bodyPr/>
+          <a:p/>
+        </p:txBody>
       </p:sp>
       <p:sp>
         <p:nvSpPr>
@@ -4837,6 +3919,10 @@
           </a:solidFill>
           <a:ln/>
         </p:spPr>
+        <p:txBody>
+          <a:bodyPr/>
+          <a:p/>
+        </p:txBody>
       </p:sp>
       <p:sp>
         <p:nvSpPr>
@@ -4942,6 +4028,10 @@
             </a:outerShdw>
           </a:effectLst>
         </p:spPr>
+        <p:txBody>
+          <a:bodyPr/>
+          <a:p/>
+        </p:txBody>
       </p:sp>
       <p:sp>
         <p:nvSpPr>
@@ -4962,6 +4052,10 @@
           </a:solidFill>
           <a:ln/>
         </p:spPr>
+        <p:txBody>
+          <a:bodyPr/>
+          <a:p/>
+        </p:txBody>
       </p:sp>
       <p:sp>
         <p:nvSpPr>
@@ -5067,6 +4161,10 @@
             </a:outerShdw>
           </a:effectLst>
         </p:spPr>
+        <p:txBody>
+          <a:bodyPr/>
+          <a:p/>
+        </p:txBody>
       </p:sp>
       <p:sp>
         <p:nvSpPr>
@@ -5087,6 +4185,10 @@
           </a:solidFill>
           <a:ln/>
         </p:spPr>
+        <p:txBody>
+          <a:bodyPr/>
+          <a:p/>
+        </p:txBody>
       </p:sp>
       <p:sp>
         <p:nvSpPr>
@@ -5192,6 +4294,10 @@
             </a:outerShdw>
           </a:effectLst>
         </p:spPr>
+        <p:txBody>
+          <a:bodyPr/>
+          <a:p/>
+        </p:txBody>
       </p:sp>
       <p:sp>
         <p:nvSpPr>
@@ -5212,6 +4318,10 @@
           </a:solidFill>
           <a:ln/>
         </p:spPr>
+        <p:txBody>
+          <a:bodyPr/>
+          <a:p/>
+        </p:txBody>
       </p:sp>
       <p:sp>
         <p:nvSpPr>
@@ -5317,6 +4427,10 @@
             </a:outerShdw>
           </a:effectLst>
         </p:spPr>
+        <p:txBody>
+          <a:bodyPr/>
+          <a:p/>
+        </p:txBody>
       </p:sp>
       <p:sp>
         <p:nvSpPr>
@@ -5337,6 +4451,10 @@
           </a:solidFill>
           <a:ln/>
         </p:spPr>
+        <p:txBody>
+          <a:bodyPr/>
+          <a:p/>
+        </p:txBody>
       </p:sp>
       <p:sp>
         <p:nvSpPr>
@@ -5467,6 +4585,10 @@
           </a:solidFill>
           <a:ln/>
         </p:spPr>
+        <p:txBody>
+          <a:bodyPr/>
+          <a:p/>
+        </p:txBody>
       </p:sp>
       <p:sp>
         <p:nvSpPr>
@@ -5611,6 +4733,10 @@
             </a:outerShdw>
           </a:effectLst>
         </p:spPr>
+        <p:txBody>
+          <a:bodyPr/>
+          <a:p/>
+        </p:txBody>
       </p:sp>
       <p:sp>
         <p:nvSpPr>
@@ -5752,6 +4878,10 @@
             </a:outerShdw>
           </a:effectLst>
         </p:spPr>
+        <p:txBody>
+          <a:bodyPr/>
+          <a:p/>
+        </p:txBody>
       </p:sp>
       <p:sp>
         <p:nvSpPr>
@@ -5893,6 +5023,10 @@
             </a:outerShdw>
           </a:effectLst>
         </p:spPr>
+        <p:txBody>
+          <a:bodyPr/>
+          <a:p/>
+        </p:txBody>
       </p:sp>
       <p:sp>
         <p:nvSpPr>
@@ -6034,6 +5168,10 @@
             </a:outerShdw>
           </a:effectLst>
         </p:spPr>
+        <p:txBody>
+          <a:bodyPr/>
+          <a:p/>
+        </p:txBody>
       </p:sp>
       <p:sp>
         <p:nvSpPr>
@@ -6515,6 +5653,10 @@
           </a:solidFill>
           <a:ln/>
         </p:spPr>
+        <p:txBody>
+          <a:bodyPr/>
+          <a:p/>
+        </p:txBody>
       </p:sp>
       <p:sp>
         <p:nvSpPr>
@@ -6620,6 +5762,10 @@
             </a:outerShdw>
           </a:effectLst>
         </p:spPr>
+        <p:txBody>
+          <a:bodyPr/>
+          <a:p/>
+        </p:txBody>
       </p:sp>
       <p:sp>
         <p:nvSpPr>
@@ -6764,6 +5910,10 @@
             </a:outerShdw>
           </a:effectLst>
         </p:spPr>
+        <p:txBody>
+          <a:bodyPr/>
+          <a:p/>
+        </p:txBody>
       </p:sp>
       <p:sp>
         <p:nvSpPr>
@@ -6908,6 +6058,10 @@
             </a:outerShdw>
           </a:effectLst>
         </p:spPr>
+        <p:txBody>
+          <a:bodyPr/>
+          <a:p/>
+        </p:txBody>
       </p:sp>
       <p:sp>
         <p:nvSpPr>
@@ -7052,6 +6206,10 @@
             </a:outerShdw>
           </a:effectLst>
         </p:spPr>
+        <p:txBody>
+          <a:bodyPr/>
+          <a:p/>
+        </p:txBody>
       </p:sp>
       <p:sp>
         <p:nvSpPr>
@@ -8874,6 +8032,10 @@
           </a:solidFill>
           <a:ln/>
         </p:spPr>
+        <p:txBody>
+          <a:bodyPr/>
+          <a:p/>
+        </p:txBody>
       </p:sp>
       <p:sp>
         <p:nvSpPr>
@@ -9057,6 +8219,10 @@
             </a:outerShdw>
           </a:effectLst>
         </p:spPr>
+        <p:txBody>
+          <a:bodyPr/>
+          <a:p/>
+        </p:txBody>
       </p:sp>
       <p:sp>
         <p:nvSpPr>
@@ -9077,6 +8243,10 @@
           </a:solidFill>
           <a:ln/>
         </p:spPr>
+        <p:txBody>
+          <a:bodyPr/>
+          <a:p/>
+        </p:txBody>
       </p:sp>
       <p:sp>
         <p:nvSpPr>
@@ -9221,6 +8391,10 @@
             </a:outerShdw>
           </a:effectLst>
         </p:spPr>
+        <p:txBody>
+          <a:bodyPr/>
+          <a:p/>
+        </p:txBody>
       </p:sp>
       <p:sp>
         <p:nvSpPr>
@@ -9241,6 +8415,10 @@
           </a:solidFill>
           <a:ln/>
         </p:spPr>
+        <p:txBody>
+          <a:bodyPr/>
+          <a:p/>
+        </p:txBody>
       </p:sp>
       <p:sp>
         <p:nvSpPr>
@@ -9385,6 +8563,10 @@
             </a:outerShdw>
           </a:effectLst>
         </p:spPr>
+        <p:txBody>
+          <a:bodyPr/>
+          <a:p/>
+        </p:txBody>
       </p:sp>
       <p:sp>
         <p:nvSpPr>
@@ -9405,6 +8587,10 @@
           </a:solidFill>
           <a:ln/>
         </p:spPr>
+        <p:txBody>
+          <a:bodyPr/>
+          <a:p/>
+        </p:txBody>
       </p:sp>
       <p:sp>
         <p:nvSpPr>
@@ -9549,6 +8735,10 @@
             </a:outerShdw>
           </a:effectLst>
         </p:spPr>
+        <p:txBody>
+          <a:bodyPr/>
+          <a:p/>
+        </p:txBody>
       </p:sp>
       <p:sp>
         <p:nvSpPr>
@@ -9569,6 +8759,10 @@
           </a:solidFill>
           <a:ln/>
         </p:spPr>
+        <p:txBody>
+          <a:bodyPr/>
+          <a:p/>
+        </p:txBody>
       </p:sp>
       <p:sp>
         <p:nvSpPr>
@@ -9738,6 +8932,10 @@
           </a:solidFill>
           <a:ln/>
         </p:spPr>
+        <p:txBody>
+          <a:bodyPr/>
+          <a:p/>
+        </p:txBody>
       </p:sp>
       <p:sp>
         <p:nvSpPr>
@@ -9848,6 +9046,10 @@
             </a:outerShdw>
           </a:effectLst>
         </p:spPr>
+        <p:txBody>
+          <a:bodyPr/>
+          <a:p/>
+        </p:txBody>
       </p:sp>
       <p:sp>
         <p:nvSpPr>
@@ -10078,6 +9280,10 @@
             </a:outerShdw>
           </a:effectLst>
         </p:spPr>
+        <p:txBody>
+          <a:bodyPr/>
+          <a:p/>
+        </p:txBody>
       </p:sp>
       <p:sp>
         <p:nvSpPr>
@@ -10308,6 +9514,10 @@
             </a:outerShdw>
           </a:effectLst>
         </p:spPr>
+        <p:txBody>
+          <a:bodyPr/>
+          <a:p/>
+        </p:txBody>
       </p:sp>
       <p:sp>
         <p:nvSpPr>
@@ -10328,6 +9538,10 @@
           </a:solidFill>
           <a:ln/>
         </p:spPr>
+        <p:txBody>
+          <a:bodyPr/>
+          <a:p/>
+        </p:txBody>
       </p:sp>
       <p:sp>
         <p:nvSpPr>
@@ -10597,6 +9811,10 @@
             </a:outerShdw>
           </a:effectLst>
         </p:spPr>
+        <p:txBody>
+          <a:bodyPr/>
+          <a:p/>
+        </p:txBody>
       </p:sp>
       <p:sp>
         <p:nvSpPr>
@@ -10828,6 +10046,10 @@
           </a:solidFill>
           <a:ln/>
         </p:spPr>
+        <p:txBody>
+          <a:bodyPr/>
+          <a:p/>
+        </p:txBody>
       </p:sp>
       <p:sp>
         <p:nvSpPr>
@@ -10926,6 +10148,10 @@
           </a:solidFill>
           <a:ln/>
         </p:spPr>
+        <p:txBody>
+          <a:bodyPr/>
+          <a:p/>
+        </p:txBody>
       </p:sp>
       <p:sp>
         <p:nvSpPr>
@@ -10985,6 +10211,10 @@
           </a:solidFill>
           <a:ln/>
         </p:spPr>
+        <p:txBody>
+          <a:bodyPr/>
+          <a:p/>
+        </p:txBody>
       </p:sp>
       <p:sp>
         <p:nvSpPr>
@@ -11005,6 +10235,10 @@
           </a:solidFill>
           <a:ln/>
         </p:spPr>
+        <p:txBody>
+          <a:bodyPr/>
+          <a:p/>
+        </p:txBody>
       </p:sp>
       <p:sp>
         <p:nvSpPr>
@@ -11064,6 +10298,10 @@
           </a:solidFill>
           <a:ln/>
         </p:spPr>
+        <p:txBody>
+          <a:bodyPr/>
+          <a:p/>
+        </p:txBody>
       </p:sp>
       <p:sp>
         <p:nvSpPr>
@@ -11084,6 +10322,10 @@
           </a:solidFill>
           <a:ln/>
         </p:spPr>
+        <p:txBody>
+          <a:bodyPr/>
+          <a:p/>
+        </p:txBody>
       </p:sp>
       <p:sp>
         <p:nvSpPr>
@@ -11143,6 +10385,10 @@
           </a:solidFill>
           <a:ln/>
         </p:spPr>
+        <p:txBody>
+          <a:bodyPr/>
+          <a:p/>
+        </p:txBody>
       </p:sp>
       <p:sp>
         <p:nvSpPr>
@@ -11163,6 +10409,10 @@
           </a:solidFill>
           <a:ln/>
         </p:spPr>
+        <p:txBody>
+          <a:bodyPr/>
+          <a:p/>
+        </p:txBody>
       </p:sp>
       <p:sp>
         <p:nvSpPr>
@@ -11222,6 +10472,10 @@
           </a:solidFill>
           <a:ln/>
         </p:spPr>
+        <p:txBody>
+          <a:bodyPr/>
+          <a:p/>
+        </p:txBody>
       </p:sp>
       <p:sp>
         <p:nvSpPr>
@@ -11242,6 +10496,10 @@
           </a:solidFill>
           <a:ln/>
         </p:spPr>
+        <p:txBody>
+          <a:bodyPr/>
+          <a:p/>
+        </p:txBody>
       </p:sp>
       <p:sp>
         <p:nvSpPr>
@@ -11301,6 +10559,10 @@
           </a:solidFill>
           <a:ln/>
         </p:spPr>
+        <p:txBody>
+          <a:bodyPr/>
+          <a:p/>
+        </p:txBody>
       </p:sp>
       <p:sp>
         <p:nvSpPr>
@@ -11321,6 +10583,10 @@
           </a:solidFill>
           <a:ln/>
         </p:spPr>
+        <p:txBody>
+          <a:bodyPr/>
+          <a:p/>
+        </p:txBody>
       </p:sp>
       <p:sp>
         <p:nvSpPr>
@@ -11380,6 +10646,10 @@
           </a:solidFill>
           <a:ln/>
         </p:spPr>
+        <p:txBody>
+          <a:bodyPr/>
+          <a:p/>
+        </p:txBody>
       </p:sp>
       <p:sp>
         <p:nvSpPr>
@@ -11400,6 +10670,10 @@
           </a:solidFill>
           <a:ln/>
         </p:spPr>
+        <p:txBody>
+          <a:bodyPr/>
+          <a:p/>
+        </p:txBody>
       </p:sp>
       <p:sp>
         <p:nvSpPr>
@@ -11459,6 +10733,10 @@
           </a:solidFill>
           <a:ln/>
         </p:spPr>
+        <p:txBody>
+          <a:bodyPr/>
+          <a:p/>
+        </p:txBody>
       </p:sp>
       <p:sp>
         <p:nvSpPr>
@@ -11479,6 +10757,10 @@
           </a:solidFill>
           <a:ln/>
         </p:spPr>
+        <p:txBody>
+          <a:bodyPr/>
+          <a:p/>
+        </p:txBody>
       </p:sp>
       <p:sp>
         <p:nvSpPr>
@@ -11538,6 +10820,10 @@
           </a:solidFill>
           <a:ln/>
         </p:spPr>
+        <p:txBody>
+          <a:bodyPr/>
+          <a:p/>
+        </p:txBody>
       </p:sp>
     </p:spTree>
   </p:cSld>
@@ -11590,6 +10876,10 @@
           </a:solidFill>
           <a:ln/>
         </p:spPr>
+        <p:txBody>
+          <a:bodyPr/>
+          <a:p/>
+        </p:txBody>
       </p:sp>
       <p:sp>
         <p:nvSpPr>
@@ -11695,6 +10985,10 @@
             </a:outerShdw>
           </a:effectLst>
         </p:spPr>
+        <p:txBody>
+          <a:bodyPr/>
+          <a:p/>
+        </p:txBody>
       </p:sp>
       <p:sp>
         <p:nvSpPr>
@@ -11715,6 +11009,10 @@
           </a:solidFill>
           <a:ln/>
         </p:spPr>
+        <p:txBody>
+          <a:bodyPr/>
+          <a:p/>
+        </p:txBody>
       </p:sp>
       <p:sp>
         <p:nvSpPr>
@@ -11735,6 +11033,10 @@
           </a:solidFill>
           <a:ln/>
         </p:spPr>
+        <p:txBody>
+          <a:bodyPr/>
+          <a:p/>
+        </p:txBody>
       </p:sp>
       <p:sp>
         <p:nvSpPr>
@@ -11879,6 +11181,10 @@
             </a:outerShdw>
           </a:effectLst>
         </p:spPr>
+        <p:txBody>
+          <a:bodyPr/>
+          <a:p/>
+        </p:txBody>
       </p:sp>
       <p:sp>
         <p:nvSpPr>
@@ -11899,6 +11205,10 @@
           </a:solidFill>
           <a:ln/>
         </p:spPr>
+        <p:txBody>
+          <a:bodyPr/>
+          <a:p/>
+        </p:txBody>
       </p:sp>
       <p:sp>
         <p:nvSpPr>
@@ -11919,6 +11229,10 @@
           </a:solidFill>
           <a:ln/>
         </p:spPr>
+        <p:txBody>
+          <a:bodyPr/>
+          <a:p/>
+        </p:txBody>
       </p:sp>
       <p:sp>
         <p:nvSpPr>
@@ -12063,6 +11377,10 @@
             </a:outerShdw>
           </a:effectLst>
         </p:spPr>
+        <p:txBody>
+          <a:bodyPr/>
+          <a:p/>
+        </p:txBody>
       </p:sp>
       <p:sp>
         <p:nvSpPr>
@@ -12083,6 +11401,10 @@
           </a:solidFill>
           <a:ln/>
         </p:spPr>
+        <p:txBody>
+          <a:bodyPr/>
+          <a:p/>
+        </p:txBody>
       </p:sp>
       <p:sp>
         <p:nvSpPr>
@@ -12103,6 +11425,10 @@
           </a:solidFill>
           <a:ln/>
         </p:spPr>
+        <p:txBody>
+          <a:bodyPr/>
+          <a:p/>
+        </p:txBody>
       </p:sp>
       <p:sp>
         <p:nvSpPr>
@@ -12247,6 +11573,10 @@
             </a:outerShdw>
           </a:effectLst>
         </p:spPr>
+        <p:txBody>
+          <a:bodyPr/>
+          <a:p/>
+        </p:txBody>
       </p:sp>
       <p:sp>
         <p:nvSpPr>
@@ -12267,6 +11597,10 @@
           </a:solidFill>
           <a:ln/>
         </p:spPr>
+        <p:txBody>
+          <a:bodyPr/>
+          <a:p/>
+        </p:txBody>
       </p:sp>
       <p:sp>
         <p:nvSpPr>
@@ -12287,6 +11621,10 @@
           </a:solidFill>
           <a:ln/>
         </p:spPr>
+        <p:txBody>
+          <a:bodyPr/>
+          <a:p/>
+        </p:txBody>
       </p:sp>
       <p:sp>
         <p:nvSpPr>
@@ -12431,6 +11769,10 @@
             </a:outerShdw>
           </a:effectLst>
         </p:spPr>
+        <p:txBody>
+          <a:bodyPr/>
+          <a:p/>
+        </p:txBody>
       </p:sp>
       <p:sp>
         <p:nvSpPr>
@@ -12451,6 +11793,10 @@
           </a:solidFill>
           <a:ln/>
         </p:spPr>
+        <p:txBody>
+          <a:bodyPr/>
+          <a:p/>
+        </p:txBody>
       </p:sp>
       <p:sp>
         <p:nvSpPr>
@@ -12471,6 +11817,10 @@
           </a:solidFill>
           <a:ln/>
         </p:spPr>
+        <p:txBody>
+          <a:bodyPr/>
+          <a:p/>
+        </p:txBody>
       </p:sp>
       <p:sp>
         <p:nvSpPr>

</xml_diff>